<commit_message>
Capa 3: incorpora la regla de selección automática entre reparto estático y cuotas aprendidas
- Lámina 16 reestructurada en tres vías: proporciones históricas, cuotas supervisadas
  y la regla que compara el WAPE de ambas en validación y adopta la de menor error
- Se retira de trabajo futuro (ya está implementada)
- Notas del orador con la respuesta exacta si el jurado pregunta por la selección

Co-authored-by: arena-agent <297053741+arena-agent@users.noreply.github.com>
</commit_message>
<xml_diff>
--- a/Defensa_Tesis_Estructurada.pptx
+++ b/Defensa_Tesis_Estructurada.pptx
@@ -1023,7 +1023,7 @@
           <a:lstStyle/>
           <a:p>
             <a:r>
-              <a:t>1 min 30 s. La Capa 3 no predice demanda: predice la cuota de cada SKU dentro de su familia. Presentar las dos vías con seguridad. La vía A usa proporciones históricas y es la que entrega el resultado principal de 16,10 %, porque es el mismo esquema que usan todos los benchmarks y eso garantiza una comparación justa. La vía B es el motor supervisado que estima la cuota mes a mes con la historia que va surgiendo, con cuota rezagada, medias móviles, meses sin venta y precio relativo. Dio 24,35 %. El hallazgo es interesante: en catálogos muy intermitentes la estabilidad le gana a la sofisticación.</a:t>
+              <a:t>1 min 45 s. La Capa 3 no predice demanda: predice la cuota de cada SKU dentro de su familia. Vía A: proporciones históricas, que es el esquema que usan todos los benchmarks y por eso garantiza una comparación justa; entrega el 16,10 %. Vía B: el motor supervisado que estima la cuota mes a mes con cuota rezagada, medias móviles, meses sin venta y precio relativo; dio 24,35 %. Y lo importante: el pipeline no elige a mano. Compara el WAPE de ambos esquemas en la ventana de validación y adopta el de menor error para la prueba ciega; en esta ventana seleccionó el reparto estático. Si el catálogo cambiara de comportamiento, la misma regla podría adoptar las cuotas aprendidas sin rediseñar nada.</a:t>
             </a:r>
           </a:p>
         </p:txBody>
@@ -15102,11 +15102,11 @@
         <p:spPr>
           <a:xfrm>
             <a:off x="960120" y="2249424"/>
-            <a:ext cx="7863840" cy="2880360"/>
+            <a:ext cx="7863840" cy="2331720"/>
           </a:xfrm>
           <a:prstGeom prst="roundRect">
             <a:avLst>
-              <a:gd name="adj" fmla="val 1904"/>
+              <a:gd name="adj" fmla="val 2352"/>
             </a:avLst>
           </a:prstGeom>
           <a:solidFill>
@@ -15147,12 +15147,12 @@
         </p:nvSpPr>
         <p:spPr>
           <a:xfrm>
-            <a:off x="1371600" y="3209544"/>
-            <a:ext cx="2286000" cy="868680"/>
+            <a:off x="1371600" y="2962656"/>
+            <a:ext cx="2286000" cy="822960"/>
           </a:xfrm>
           <a:prstGeom prst="roundRect">
             <a:avLst>
-              <a:gd name="adj" fmla="val 6315"/>
+              <a:gd name="adj" fmla="val 6666"/>
             </a:avLst>
           </a:prstGeom>
           <a:solidFill>
@@ -15193,8 +15193,8 @@
         </p:nvSpPr>
         <p:spPr>
           <a:xfrm>
-            <a:off x="1371600" y="3209544"/>
-            <a:ext cx="2286000" cy="868680"/>
+            <a:off x="1371600" y="2962656"/>
+            <a:ext cx="2286000" cy="822960"/>
           </a:xfrm>
           <a:prstGeom prst="rect">
             <a:avLst/>
@@ -15219,7 +15219,7 @@
               </a:spcAft>
             </a:pPr>
             <a:r>
-              <a:rPr sz="1500" b="1" i="0">
+              <a:rPr sz="1450" b="1" i="0">
                 <a:solidFill>
                   <a:srgbClr val="FFFFFF"/>
                 </a:solidFill>
@@ -15241,7 +15241,7 @@
               </a:spcAft>
             </a:pPr>
             <a:r>
-              <a:rPr sz="1100" b="0" i="0">
+              <a:rPr sz="1050" b="0" i="0">
                 <a:solidFill>
                   <a:srgbClr val="CBDCE7"/>
                 </a:solidFill>
@@ -15260,12 +15260,12 @@
         </p:nvSpPr>
         <p:spPr>
           <a:xfrm>
-            <a:off x="5166359" y="2523744"/>
-            <a:ext cx="3200400" cy="502920"/>
+            <a:off x="5166359" y="2487168"/>
+            <a:ext cx="3200400" cy="420624"/>
           </a:xfrm>
           <a:prstGeom prst="roundRect">
             <a:avLst>
-              <a:gd name="adj" fmla="val 9090"/>
+              <a:gd name="adj" fmla="val 8695"/>
             </a:avLst>
           </a:prstGeom>
           <a:solidFill>
@@ -15308,8 +15308,8 @@
         </p:nvSpPr>
         <p:spPr>
           <a:xfrm>
-            <a:off x="5394959" y="2523744"/>
-            <a:ext cx="1463040" cy="502920"/>
+            <a:off x="5394959" y="2487168"/>
+            <a:ext cx="1463040" cy="420624"/>
           </a:xfrm>
           <a:prstGeom prst="rect">
             <a:avLst/>
@@ -15334,7 +15334,7 @@
               </a:spcAft>
             </a:pPr>
             <a:r>
-              <a:rPr sz="1300" b="1" i="0">
+              <a:rPr sz="1250" b="1" i="0">
                 <a:solidFill>
                   <a:srgbClr val="13161B"/>
                 </a:solidFill>
@@ -15353,8 +15353,8 @@
         </p:nvSpPr>
         <p:spPr>
           <a:xfrm>
-            <a:off x="6720840" y="2523744"/>
-            <a:ext cx="1463040" cy="502920"/>
+            <a:off x="6720840" y="2487168"/>
+            <a:ext cx="1463040" cy="420624"/>
           </a:xfrm>
           <a:prstGeom prst="rect">
             <a:avLst/>
@@ -15379,7 +15379,7 @@
               </a:spcAft>
             </a:pPr>
             <a:r>
-              <a:rPr sz="1300" b="1" i="0">
+              <a:rPr sz="1250" b="1" i="0">
                 <a:solidFill>
                   <a:srgbClr val="005F91"/>
                 </a:solidFill>
@@ -15398,8 +15398,8 @@
         </p:nvCxnSpPr>
         <p:spPr>
           <a:xfrm flipV="1">
-            <a:off x="3749039" y="2770632"/>
-            <a:ext cx="1325881" cy="868680"/>
+            <a:off x="3749039" y="2697479"/>
+            <a:ext cx="1325881" cy="676657"/>
           </a:xfrm>
           <a:prstGeom prst="line">
             <a:avLst/>
@@ -15434,12 +15434,12 @@
         </p:nvSpPr>
         <p:spPr>
           <a:xfrm>
-            <a:off x="5166359" y="3072384"/>
-            <a:ext cx="3200400" cy="502920"/>
+            <a:off x="5166359" y="2962656"/>
+            <a:ext cx="3200400" cy="420624"/>
           </a:xfrm>
           <a:prstGeom prst="roundRect">
             <a:avLst>
-              <a:gd name="adj" fmla="val 9090"/>
+              <a:gd name="adj" fmla="val 8695"/>
             </a:avLst>
           </a:prstGeom>
           <a:solidFill>
@@ -15482,8 +15482,8 @@
         </p:nvSpPr>
         <p:spPr>
           <a:xfrm>
-            <a:off x="5394959" y="3072384"/>
-            <a:ext cx="1463040" cy="502920"/>
+            <a:off x="5394959" y="2962656"/>
+            <a:ext cx="1463040" cy="420624"/>
           </a:xfrm>
           <a:prstGeom prst="rect">
             <a:avLst/>
@@ -15508,7 +15508,7 @@
               </a:spcAft>
             </a:pPr>
             <a:r>
-              <a:rPr sz="1300" b="1" i="0">
+              <a:rPr sz="1250" b="1" i="0">
                 <a:solidFill>
                   <a:srgbClr val="13161B"/>
                 </a:solidFill>
@@ -15527,8 +15527,8 @@
         </p:nvSpPr>
         <p:spPr>
           <a:xfrm>
-            <a:off x="6720840" y="3072384"/>
-            <a:ext cx="1463040" cy="502920"/>
+            <a:off x="6720840" y="2962656"/>
+            <a:ext cx="1463040" cy="420624"/>
           </a:xfrm>
           <a:prstGeom prst="rect">
             <a:avLst/>
@@ -15553,7 +15553,7 @@
               </a:spcAft>
             </a:pPr>
             <a:r>
-              <a:rPr sz="1300" b="1" i="0">
+              <a:rPr sz="1250" b="1" i="0">
                 <a:solidFill>
                   <a:srgbClr val="005F91"/>
                 </a:solidFill>
@@ -15572,8 +15572,8 @@
         </p:nvCxnSpPr>
         <p:spPr>
           <a:xfrm flipV="1">
-            <a:off x="3749039" y="3319272"/>
-            <a:ext cx="1325881" cy="320040"/>
+            <a:off x="3749039" y="3172968"/>
+            <a:ext cx="1325881" cy="201168"/>
           </a:xfrm>
           <a:prstGeom prst="line">
             <a:avLst/>
@@ -15608,12 +15608,12 @@
         </p:nvSpPr>
         <p:spPr>
           <a:xfrm>
-            <a:off x="5166359" y="3621024"/>
-            <a:ext cx="3200400" cy="502920"/>
+            <a:off x="5166359" y="3438144"/>
+            <a:ext cx="3200400" cy="420624"/>
           </a:xfrm>
           <a:prstGeom prst="roundRect">
             <a:avLst>
-              <a:gd name="adj" fmla="val 9090"/>
+              <a:gd name="adj" fmla="val 8695"/>
             </a:avLst>
           </a:prstGeom>
           <a:solidFill>
@@ -15656,8 +15656,8 @@
         </p:nvSpPr>
         <p:spPr>
           <a:xfrm>
-            <a:off x="5394959" y="3621024"/>
-            <a:ext cx="1463040" cy="502920"/>
+            <a:off x="5394959" y="3438144"/>
+            <a:ext cx="1463040" cy="420624"/>
           </a:xfrm>
           <a:prstGeom prst="rect">
             <a:avLst/>
@@ -15682,7 +15682,7 @@
               </a:spcAft>
             </a:pPr>
             <a:r>
-              <a:rPr sz="1300" b="1" i="0">
+              <a:rPr sz="1250" b="1" i="0">
                 <a:solidFill>
                   <a:srgbClr val="13161B"/>
                 </a:solidFill>
@@ -15701,8 +15701,8 @@
         </p:nvSpPr>
         <p:spPr>
           <a:xfrm>
-            <a:off x="6720840" y="3621024"/>
-            <a:ext cx="1463040" cy="502920"/>
+            <a:off x="6720840" y="3438144"/>
+            <a:ext cx="1463040" cy="420624"/>
           </a:xfrm>
           <a:prstGeom prst="rect">
             <a:avLst/>
@@ -15727,7 +15727,7 @@
               </a:spcAft>
             </a:pPr>
             <a:r>
-              <a:rPr sz="1300" b="1" i="0">
+              <a:rPr sz="1250" b="1" i="0">
                 <a:solidFill>
                   <a:srgbClr val="005F91"/>
                 </a:solidFill>
@@ -15746,8 +15746,8 @@
         </p:nvCxnSpPr>
         <p:spPr>
           <a:xfrm>
-            <a:off x="3749039" y="3639312"/>
-            <a:ext cx="1325881" cy="228600"/>
+            <a:off x="3749039" y="3374136"/>
+            <a:ext cx="1325881" cy="274320"/>
           </a:xfrm>
           <a:prstGeom prst="line">
             <a:avLst/>
@@ -15782,12 +15782,12 @@
         </p:nvSpPr>
         <p:spPr>
           <a:xfrm>
-            <a:off x="5166359" y="4169663"/>
-            <a:ext cx="3200400" cy="502920"/>
+            <a:off x="5166359" y="3913631"/>
+            <a:ext cx="3200400" cy="420624"/>
           </a:xfrm>
           <a:prstGeom prst="roundRect">
             <a:avLst>
-              <a:gd name="adj" fmla="val 9090"/>
+              <a:gd name="adj" fmla="val 8695"/>
             </a:avLst>
           </a:prstGeom>
           <a:solidFill>
@@ -15830,8 +15830,8 @@
         </p:nvSpPr>
         <p:spPr>
           <a:xfrm>
-            <a:off x="5394959" y="4169663"/>
-            <a:ext cx="1463040" cy="502920"/>
+            <a:off x="5394959" y="3913631"/>
+            <a:ext cx="1463040" cy="420624"/>
           </a:xfrm>
           <a:prstGeom prst="rect">
             <a:avLst/>
@@ -15856,7 +15856,7 @@
               </a:spcAft>
             </a:pPr>
             <a:r>
-              <a:rPr sz="1300" b="1" i="0">
+              <a:rPr sz="1250" b="1" i="0">
                 <a:solidFill>
                   <a:srgbClr val="13161B"/>
                 </a:solidFill>
@@ -15875,8 +15875,8 @@
         </p:nvSpPr>
         <p:spPr>
           <a:xfrm>
-            <a:off x="6720840" y="4169663"/>
-            <a:ext cx="1463040" cy="502920"/>
+            <a:off x="6720840" y="3913631"/>
+            <a:ext cx="1463040" cy="420624"/>
           </a:xfrm>
           <a:prstGeom prst="rect">
             <a:avLst/>
@@ -15901,7 +15901,7 @@
               </a:spcAft>
             </a:pPr>
             <a:r>
-              <a:rPr sz="1300" b="1" i="0">
+              <a:rPr sz="1250" b="1" i="0">
                 <a:solidFill>
                   <a:srgbClr val="005F91"/>
                 </a:solidFill>
@@ -15920,8 +15920,8 @@
         </p:nvCxnSpPr>
         <p:spPr>
           <a:xfrm>
-            <a:off x="3749039" y="3639312"/>
-            <a:ext cx="1325881" cy="777240"/>
+            <a:off x="3749039" y="3374136"/>
+            <a:ext cx="1325881" cy="749808"/>
           </a:xfrm>
           <a:prstGeom prst="line">
             <a:avLst/>
@@ -15956,8 +15956,8 @@
         </p:nvSpPr>
         <p:spPr>
           <a:xfrm>
-            <a:off x="1371600" y="4700016"/>
-            <a:ext cx="7040880" cy="384048"/>
+            <a:off x="1371600" y="4096512"/>
+            <a:ext cx="3291840" cy="365760"/>
           </a:xfrm>
           <a:prstGeom prst="rect">
             <a:avLst/>
@@ -15972,7 +15972,7 @@
           <a:p>
             <a:pPr algn="l">
               <a:lnSpc>
-                <a:spcPct val="120000"/>
+                <a:spcPct val="116000"/>
               </a:lnSpc>
               <a:spcBef>
                 <a:spcPts val="0"/>
@@ -15988,7 +15988,7 @@
                 </a:solidFill>
                 <a:latin typeface="Open Sans"/>
               </a:rPr>
-              <a:t>La cuota de cada SKU reparte la demanda de su familia; las cuotas suman exactamente 100 %.</a:t>
+              <a:t>Las cuotas suman 100 %</a:t>
             </a:r>
           </a:p>
         </p:txBody>
@@ -16002,11 +16002,11 @@
         <p:spPr>
           <a:xfrm>
             <a:off x="9464040" y="2249424"/>
-            <a:ext cx="7863840" cy="2880360"/>
+            <a:ext cx="7863840" cy="2331720"/>
           </a:xfrm>
           <a:prstGeom prst="roundRect">
             <a:avLst>
-              <a:gd name="adj" fmla="val 1746"/>
+              <a:gd name="adj" fmla="val 2156"/>
             </a:avLst>
           </a:prstGeom>
           <a:solidFill>
@@ -16048,7 +16048,7 @@
         <p:spPr>
           <a:xfrm>
             <a:off x="9464040" y="2249424"/>
-            <a:ext cx="68580" cy="2880360"/>
+            <a:ext cx="68580" cy="2331720"/>
           </a:xfrm>
           <a:prstGeom prst="rect">
             <a:avLst/>
@@ -16092,7 +16092,7 @@
         <p:spPr>
           <a:xfrm>
             <a:off x="9921240" y="2578608"/>
-            <a:ext cx="7022592" cy="2221992"/>
+            <a:ext cx="7022592" cy="1673352"/>
           </a:xfrm>
           <a:prstGeom prst="rect">
             <a:avLst/>
@@ -16117,7 +16117,7 @@
               </a:spcAft>
             </a:pPr>
             <a:r>
-              <a:rPr sz="1750" b="1" i="0">
+              <a:rPr sz="1700" b="1" i="0">
                 <a:solidFill>
                   <a:srgbClr val="13161B"/>
                 </a:solidFill>
@@ -16139,13 +16139,13 @@
               </a:spcAft>
             </a:pPr>
             <a:r>
-              <a:rPr sz="1380" b="0" i="0">
+              <a:rPr sz="1340" b="0" i="0">
                 <a:solidFill>
                   <a:srgbClr val="394049"/>
                 </a:solidFill>
                 <a:latin typeface="Open Sans"/>
               </a:rPr>
-              <a:t>•	No la demanda del SKU, sino su participación dentro de la familia.</a:t>
+              <a:t>•	No la demanda del SKU, sino su participación dentro de la familia; la demanda familiar se multiplica por esa cuota.</a:t>
             </a:r>
           </a:p>
           <a:p>
@@ -16157,33 +16157,11 @@
                 <a:spcPts val="0"/>
               </a:spcBef>
               <a:spcAft>
-                <a:spcPts val="700"/>
-              </a:spcAft>
-            </a:pPr>
-            <a:r>
-              <a:rPr sz="1380" b="0" i="0">
-                <a:solidFill>
-                  <a:srgbClr val="394049"/>
-                </a:solidFill>
-                <a:latin typeface="Open Sans"/>
-              </a:rPr>
-              <a:t>•	La demanda familiar se multiplica por esa cuota y se obtiene el pronóstico del producto.</a:t>
-            </a:r>
-          </a:p>
-          <a:p>
-            <a:pPr algn="l" marL="274320" indent="-274320">
-              <a:lnSpc>
-                <a:spcPct val="118000"/>
-              </a:lnSpc>
-              <a:spcBef>
-                <a:spcPts val="0"/>
-              </a:spcBef>
-              <a:spcAft>
-                <a:spcPts val="0"/>
-              </a:spcAft>
-            </a:pPr>
-            <a:r>
-              <a:rPr sz="1380" b="0" i="0">
+                <a:spcPts val="0"/>
+              </a:spcAft>
+            </a:pPr>
+            <a:r>
+              <a:rPr sz="1340" b="0" i="0">
                 <a:solidFill>
                   <a:srgbClr val="394049"/>
                 </a:solidFill>
@@ -16202,12 +16180,12 @@
         </p:nvSpPr>
         <p:spPr>
           <a:xfrm>
-            <a:off x="960120" y="5404104"/>
-            <a:ext cx="7863840" cy="2743200"/>
+            <a:off x="960120" y="4855464"/>
+            <a:ext cx="5239512" cy="3520440"/>
           </a:xfrm>
           <a:prstGeom prst="roundRect">
             <a:avLst>
-              <a:gd name="adj" fmla="val 1833"/>
+              <a:gd name="adj" fmla="val 1428"/>
             </a:avLst>
           </a:prstGeom>
           <a:solidFill>
@@ -16248,8 +16226,8 @@
         </p:nvSpPr>
         <p:spPr>
           <a:xfrm>
-            <a:off x="960120" y="5404104"/>
-            <a:ext cx="68580" cy="2743200"/>
+            <a:off x="960120" y="4855464"/>
+            <a:ext cx="68580" cy="3520440"/>
           </a:xfrm>
           <a:prstGeom prst="rect">
             <a:avLst/>
@@ -16292,8 +16270,8 @@
         </p:nvSpPr>
         <p:spPr>
           <a:xfrm>
-            <a:off x="1417320" y="5733288"/>
-            <a:ext cx="7022592" cy="2084832"/>
+            <a:off x="1417320" y="5184648"/>
+            <a:ext cx="4398264" cy="2862072"/>
           </a:xfrm>
           <a:prstGeom prst="rect">
             <a:avLst/>
@@ -16336,17 +16314,17 @@
                 <a:spcPts val="0"/>
               </a:spcBef>
               <a:spcAft>
-                <a:spcPts val="700"/>
-              </a:spcAft>
-            </a:pPr>
-            <a:r>
-              <a:rPr sz="1360" b="0" i="0">
+                <a:spcPts val="1000"/>
+              </a:spcAft>
+            </a:pPr>
+            <a:r>
+              <a:rPr sz="1340" b="0" i="0">
                 <a:solidFill>
                   <a:srgbClr val="394049"/>
                 </a:solidFill>
                 <a:latin typeface="Open Sans"/>
               </a:rPr>
-              <a:t>•	La cuota se calcula con las ventas del período de entrenamiento y se mantiene fija en el test.</a:t>
+              <a:t>•	La cuota se calcula con las ventas del período de entrenamiento y se mantiene fija durante el test.</a:t>
             </a:r>
           </a:p>
           <a:p>
@@ -16358,11 +16336,11 @@
                 <a:spcPts val="0"/>
               </a:spcBef>
               <a:spcAft>
-                <a:spcPts val="700"/>
-              </a:spcAft>
-            </a:pPr>
-            <a:r>
-              <a:rPr sz="1360" b="0" i="0">
+                <a:spcPts val="1000"/>
+              </a:spcAft>
+            </a:pPr>
+            <a:r>
+              <a:rPr sz="1340" b="0" i="0">
                 <a:solidFill>
                   <a:srgbClr val="394049"/>
                 </a:solidFill>
@@ -16380,17 +16358,17 @@
                 <a:spcPts val="0"/>
               </a:spcBef>
               <a:spcAft>
-                <a:spcPts val="0"/>
-              </a:spcAft>
-            </a:pPr>
-            <a:r>
-              <a:rPr sz="1360" b="1" i="0">
-                <a:solidFill>
-                  <a:srgbClr val="394049"/>
-                </a:solidFill>
-                <a:latin typeface="Open Sans"/>
-              </a:rPr>
-              <a:t>•	Resultado principal de la tesis: WAPE 16,10 %.</a:t>
+                <a:spcPts val="1000"/>
+              </a:spcAft>
+            </a:pPr>
+            <a:r>
+              <a:rPr sz="1340" b="1" i="0">
+                <a:solidFill>
+                  <a:srgbClr val="13161B"/>
+                </a:solidFill>
+                <a:latin typeface="Open Sans"/>
+              </a:rPr>
+              <a:t>•	Resultado principal: WAPE 16,10 %.</a:t>
             </a:r>
           </a:p>
         </p:txBody>
@@ -16403,12 +16381,12 @@
         </p:nvSpPr>
         <p:spPr>
           <a:xfrm>
-            <a:off x="9464040" y="5404104"/>
-            <a:ext cx="7863840" cy="2743200"/>
+            <a:off x="6519672" y="4855464"/>
+            <a:ext cx="5239512" cy="3520440"/>
           </a:xfrm>
           <a:prstGeom prst="roundRect">
             <a:avLst>
-              <a:gd name="adj" fmla="val 1833"/>
+              <a:gd name="adj" fmla="val 1428"/>
             </a:avLst>
           </a:prstGeom>
           <a:solidFill>
@@ -16449,8 +16427,209 @@
         </p:nvSpPr>
         <p:spPr>
           <a:xfrm>
-            <a:off x="9464040" y="5404104"/>
-            <a:ext cx="68580" cy="2743200"/>
+            <a:off x="6519672" y="4855464"/>
+            <a:ext cx="68580" cy="3520440"/>
+          </a:xfrm>
+          <a:prstGeom prst="rect">
+            <a:avLst/>
+          </a:prstGeom>
+          <a:solidFill>
+            <a:srgbClr val="13161B"/>
+          </a:solidFill>
+          <a:ln>
+            <a:noFill/>
+          </a:ln>
+          <a:effectLst/>
+        </p:spPr>
+        <p:style>
+          <a:lnRef idx="1">
+            <a:schemeClr val="accent1"/>
+          </a:lnRef>
+          <a:fillRef idx="3">
+            <a:schemeClr val="accent1"/>
+          </a:fillRef>
+          <a:effectRef idx="2">
+            <a:schemeClr val="accent1"/>
+          </a:effectRef>
+          <a:fontRef idx="minor">
+            <a:schemeClr val="lt1"/>
+          </a:fontRef>
+        </p:style>
+        <p:txBody>
+          <a:bodyPr rtlCol="0" anchor="ctr" wrap="none"/>
+          <a:lstStyle/>
+          <a:p>
+            <a:pPr algn="ctr"/>
+          </a:p>
+        </p:txBody>
+      </p:sp>
+      <p:sp>
+        <p:nvSpPr>
+          <p:cNvPr id="38" name="TextBox 37"/>
+          <p:cNvSpPr txBox="1"/>
+          <p:nvPr/>
+        </p:nvSpPr>
+        <p:spPr>
+          <a:xfrm>
+            <a:off x="6976872" y="5184648"/>
+            <a:ext cx="4398264" cy="2862072"/>
+          </a:xfrm>
+          <a:prstGeom prst="rect">
+            <a:avLst/>
+          </a:prstGeom>
+          <a:noFill/>
+        </p:spPr>
+        <p:txBody>
+          <a:bodyPr wrap="square" lIns="0" rIns="0" tIns="0" bIns="0" anchor="t">
+            <a:spAutoFit/>
+          </a:bodyPr>
+          <a:lstStyle/>
+          <a:p>
+            <a:pPr algn="l">
+              <a:lnSpc>
+                <a:spcPct val="112000"/>
+              </a:lnSpc>
+              <a:spcBef>
+                <a:spcPts val="0"/>
+              </a:spcBef>
+              <a:spcAft>
+                <a:spcPts val="800"/>
+              </a:spcAft>
+            </a:pPr>
+            <a:r>
+              <a:rPr sz="1700" b="1" i="0">
+                <a:solidFill>
+                  <a:srgbClr val="13161B"/>
+                </a:solidFill>
+                <a:latin typeface="Open Sans"/>
+              </a:rPr>
+              <a:t>Vía B · cuotas supervisadas</a:t>
+            </a:r>
+          </a:p>
+          <a:p>
+            <a:pPr algn="l" marL="274320" indent="-274320">
+              <a:lnSpc>
+                <a:spcPct val="118000"/>
+              </a:lnSpc>
+              <a:spcBef>
+                <a:spcPts val="0"/>
+              </a:spcBef>
+              <a:spcAft>
+                <a:spcPts val="1000"/>
+              </a:spcAft>
+            </a:pPr>
+            <a:r>
+              <a:rPr sz="1340" b="0" i="0">
+                <a:solidFill>
+                  <a:srgbClr val="394049"/>
+                </a:solidFill>
+                <a:latin typeface="Open Sans"/>
+              </a:rPr>
+              <a:t>•	LightGBM, XGBoost y CatBoost predicen la cuota mes a mes con la historia que va surgiendo.</a:t>
+            </a:r>
+          </a:p>
+          <a:p>
+            <a:pPr algn="l" marL="274320" indent="-274320">
+              <a:lnSpc>
+                <a:spcPct val="118000"/>
+              </a:lnSpc>
+              <a:spcBef>
+                <a:spcPts val="0"/>
+              </a:spcBef>
+              <a:spcAft>
+                <a:spcPts val="1000"/>
+              </a:spcAft>
+            </a:pPr>
+            <a:r>
+              <a:rPr sz="1340" b="0" i="0">
+                <a:solidFill>
+                  <a:srgbClr val="394049"/>
+                </a:solidFill>
+                <a:latin typeface="Open Sans"/>
+              </a:rPr>
+              <a:t>•	Variables: cuota rezagada en t−1 y t−12, medias móviles de 3 y 12 meses, meses desde la última venta y precio relativo del SKU.</a:t>
+            </a:r>
+          </a:p>
+          <a:p>
+            <a:pPr algn="l" marL="274320" indent="-274320">
+              <a:lnSpc>
+                <a:spcPct val="118000"/>
+              </a:lnSpc>
+              <a:spcBef>
+                <a:spcPts val="0"/>
+              </a:spcBef>
+              <a:spcAft>
+                <a:spcPts val="1000"/>
+              </a:spcAft>
+            </a:pPr>
+            <a:r>
+              <a:rPr sz="1340" b="1" i="0">
+                <a:solidFill>
+                  <a:srgbClr val="13161B"/>
+                </a:solidFill>
+                <a:latin typeface="Open Sans"/>
+              </a:rPr>
+              <a:t>•	Evaluada en la misma ventana: WAPE 24,35 %.</a:t>
+            </a:r>
+          </a:p>
+        </p:txBody>
+      </p:sp>
+      <p:sp>
+        <p:nvSpPr>
+          <p:cNvPr id="39" name="Rounded Rectangle 38"/>
+          <p:cNvSpPr/>
+          <p:nvPr/>
+        </p:nvSpPr>
+        <p:spPr>
+          <a:xfrm>
+            <a:off x="12079224" y="4855464"/>
+            <a:ext cx="5239512" cy="3520440"/>
+          </a:xfrm>
+          <a:prstGeom prst="roundRect">
+            <a:avLst>
+              <a:gd name="adj" fmla="val 1428"/>
+            </a:avLst>
+          </a:prstGeom>
+          <a:solidFill>
+            <a:srgbClr val="F5F7F9"/>
+          </a:solidFill>
+          <a:ln>
+            <a:noFill/>
+          </a:ln>
+          <a:effectLst/>
+        </p:spPr>
+        <p:style>
+          <a:lnRef idx="1">
+            <a:schemeClr val="accent1"/>
+          </a:lnRef>
+          <a:fillRef idx="3">
+            <a:schemeClr val="accent1"/>
+          </a:fillRef>
+          <a:effectRef idx="2">
+            <a:schemeClr val="accent1"/>
+          </a:effectRef>
+          <a:fontRef idx="minor">
+            <a:schemeClr val="lt1"/>
+          </a:fontRef>
+        </p:style>
+        <p:txBody>
+          <a:bodyPr rtlCol="0" anchor="ctr" wrap="none"/>
+          <a:lstStyle/>
+          <a:p>
+            <a:pPr algn="ctr"/>
+          </a:p>
+        </p:txBody>
+      </p:sp>
+      <p:sp>
+        <p:nvSpPr>
+          <p:cNvPr id="40" name="Rectangle 39"/>
+          <p:cNvSpPr/>
+          <p:nvPr/>
+        </p:nvSpPr>
+        <p:spPr>
+          <a:xfrm>
+            <a:off x="12079224" y="4855464"/>
+            <a:ext cx="68580" cy="3520440"/>
           </a:xfrm>
           <a:prstGeom prst="rect">
             <a:avLst/>
@@ -16487,14 +16666,14 @@
       </p:sp>
       <p:sp>
         <p:nvSpPr>
-          <p:cNvPr id="38" name="TextBox 37"/>
+          <p:cNvPr id="41" name="TextBox 40"/>
           <p:cNvSpPr txBox="1"/>
           <p:nvPr/>
         </p:nvSpPr>
         <p:spPr>
           <a:xfrm>
-            <a:off x="9921240" y="5733288"/>
-            <a:ext cx="7022592" cy="2084832"/>
+            <a:off x="12536424" y="5184648"/>
+            <a:ext cx="4398264" cy="2862072"/>
           </a:xfrm>
           <a:prstGeom prst="rect">
             <a:avLst/>
@@ -16525,7 +16704,7 @@
                 </a:solidFill>
                 <a:latin typeface="Open Sans"/>
               </a:rPr>
-              <a:t>Vía B · cuotas supervisadas (dinámicas)</a:t>
+              <a:t>Regla de selección en validación</a:t>
             </a:r>
           </a:p>
           <a:p>
@@ -16537,17 +16716,17 @@
                 <a:spcPts val="0"/>
               </a:spcBef>
               <a:spcAft>
-                <a:spcPts val="700"/>
-              </a:spcAft>
-            </a:pPr>
-            <a:r>
-              <a:rPr sz="1360" b="0" i="0">
+                <a:spcPts val="1000"/>
+              </a:spcAft>
+            </a:pPr>
+            <a:r>
+              <a:rPr sz="1340" b="0" i="0">
                 <a:solidFill>
                   <a:srgbClr val="394049"/>
                 </a:solidFill>
                 <a:latin typeface="Open Sans"/>
               </a:rPr>
-              <a:t>•	LightGBM, XGBoost y CatBoost predicen la cuota mes a mes con la historia que va surgiendo.</a:t>
+              <a:t>•	El pipeline compara el WAPE de ambos esquemas sobre la ventana de validación.</a:t>
             </a:r>
           </a:p>
           <a:p>
@@ -16559,17 +16738,17 @@
                 <a:spcPts val="0"/>
               </a:spcBef>
               <a:spcAft>
-                <a:spcPts val="700"/>
-              </a:spcAft>
-            </a:pPr>
-            <a:r>
-              <a:rPr sz="1360" b="0" i="0">
+                <a:spcPts val="1000"/>
+              </a:spcAft>
+            </a:pPr>
+            <a:r>
+              <a:rPr sz="1340" b="0" i="0">
                 <a:solidFill>
                   <a:srgbClr val="394049"/>
                 </a:solidFill>
                 <a:latin typeface="Open Sans"/>
               </a:rPr>
-              <a:t>•	Variables: cuota rezagada en t−1 y t−12, medias móviles de 3 y 12 meses, meses desde la última venta y precio relativo del SKU frente a su familia.</a:t>
+              <a:t>•	Adopta el de menor error para la prueba ciega, sin intervención manual.</a:t>
             </a:r>
           </a:p>
           <a:p>
@@ -16581,35 +16760,35 @@
                 <a:spcPts val="0"/>
               </a:spcBef>
               <a:spcAft>
-                <a:spcPts val="0"/>
-              </a:spcAft>
-            </a:pPr>
-            <a:r>
-              <a:rPr sz="1360" b="1" i="0">
+                <a:spcPts val="1000"/>
+              </a:spcAft>
+            </a:pPr>
+            <a:r>
+              <a:rPr sz="1340" b="0" i="0">
                 <a:solidFill>
                   <a:srgbClr val="394049"/>
                 </a:solidFill>
                 <a:latin typeface="Open Sans"/>
               </a:rPr>
-              <a:t>•	Extensión metodológica evaluada: WAPE 24,35 %.</a:t>
-            </a:r>
-          </a:p>
-        </p:txBody>
-      </p:sp>
-      <p:sp>
-        <p:nvSpPr>
-          <p:cNvPr id="39" name="Rounded Rectangle 38"/>
+              <a:t>•	En esta ventana seleccionó el reparto estático; si el catálogo cambia, la misma regla puede adoptar las cuotas aprendidas.</a:t>
+            </a:r>
+          </a:p>
+        </p:txBody>
+      </p:sp>
+      <p:sp>
+        <p:nvSpPr>
+          <p:cNvPr id="42" name="Rounded Rectangle 41"/>
           <p:cNvSpPr/>
           <p:nvPr/>
         </p:nvSpPr>
         <p:spPr>
           <a:xfrm>
-            <a:off x="960120" y="8421624"/>
-            <a:ext cx="16367759" cy="731520"/>
+            <a:off x="960120" y="8604504"/>
+            <a:ext cx="16367759" cy="658368"/>
           </a:xfrm>
           <a:prstGeom prst="roundRect">
             <a:avLst>
-              <a:gd name="adj" fmla="val 6874"/>
+              <a:gd name="adj" fmla="val 7638"/>
             </a:avLst>
           </a:prstGeom>
           <a:solidFill>
@@ -16644,14 +16823,14 @@
       </p:sp>
       <p:sp>
         <p:nvSpPr>
-          <p:cNvPr id="40" name="TextBox 39"/>
+          <p:cNvPr id="43" name="TextBox 42"/>
           <p:cNvSpPr txBox="1"/>
           <p:nvPr/>
         </p:nvSpPr>
         <p:spPr>
           <a:xfrm>
-            <a:off x="1417320" y="8421624"/>
-            <a:ext cx="15453359" cy="731520"/>
+            <a:off x="1417320" y="8604504"/>
+            <a:ext cx="15453359" cy="658368"/>
           </a:xfrm>
           <a:prstGeom prst="rect">
             <a:avLst/>
@@ -16676,13 +16855,13 @@
               </a:spcAft>
             </a:pPr>
             <a:r>
-              <a:rPr sz="1500" b="0" i="0">
+              <a:rPr sz="1450" b="0" i="0">
                 <a:solidFill>
                   <a:srgbClr val="394049"/>
                 </a:solidFill>
                 <a:latin typeface="Open Sans"/>
               </a:rPr>
-              <a:t>Hallazgo: en catálogos con alta intermitencia, la estabilidad de las proporciones históricas venció a la sofisticación de las cuotas aprendidas.</a:t>
+              <a:t>En catálogos con alta intermitencia, la estabilidad de las proporciones históricas le ganó a la sofisticación de las cuotas aprendidas.</a:t>
             </a:r>
           </a:p>
         </p:txBody>

</xml_diff>

<commit_message>
Validación cifra por cifra contra el PDF de la tesis
- 395 cifras del deck contrastadas automáticamente contra el texto de la memoria
- Elimina el valor inventado tau* = 1,25: la tesis publica el rango [1,05; 1,50]
  pero no el óptimo, así que la grilla ahora se muestra como rango sin valor puntual
- Corrige la atribución de 1970 a la heurística estacional (era SARIMA)
- Precisión terminológica: vida media de 24 meses (no decay de 24 meses) y
  escala log(1 + unidades / (nivel + 1)) según la formulación del documento
- Capa 2: los multiplicadores estacionales los aprenden los modelos, no el Holt
  (la tesis especifica Holt damped sin componente estacional)

Co-authored-by: arena-agent <297053741+arena-agent@users.noreply.github.com>
</commit_message>
<xml_diff>
--- a/Defensa_Tesis_Estructurada.pptx
+++ b/Defensa_Tesis_Estructurada.pptx
@@ -10234,7 +10234,7 @@
                 </a:solidFill>
                 <a:latin typeface="Open Sans"/>
               </a:rPr>
-              <a:t>Desde la heurística estacional de 1970 hasta los modelos fundacionales pre-entrenados de 2024.</a:t>
+              <a:t>Desde las heurísticas estacionales clásicas hasta los modelos fundacionales pre-entrenados de 2024.</a:t>
             </a:r>
           </a:p>
         </p:txBody>
@@ -11271,7 +11271,7 @@
                 </a:solidFill>
                 <a:latin typeface="Open Sans"/>
               </a:rPr>
-              <a:t>•	Escala arcsinh con decay de 24 meses</a:t>
+              <a:t>•	Escala arcsinh, decay con vida media de 24 meses</a:t>
             </a:r>
           </a:p>
           <a:p>
@@ -11608,7 +11608,7 @@
                 </a:solidFill>
                 <a:latin typeface="Open Sans"/>
               </a:rPr>
-              <a:t>•	Escala log(1 + unidades / nivel)</a:t>
+              <a:t>•	Escala log(1 + unidades / (nivel + 1))</a:t>
             </a:r>
           </a:p>
           <a:p>
@@ -13538,7 +13538,7 @@
                 </a:solidFill>
                 <a:latin typeface="Open Sans"/>
               </a:rPr>
-              <a:t>•	Filtra ruido y conserva estacionalidad: menor varianza, pero reacciona más tarde.</a:t>
+              <a:t>•	Sobre ese nivel aprenden los residuos y los multiplicadores estacionales: menor varianza, pero reacciona más tarde.</a:t>
             </a:r>
           </a:p>
         </p:txBody>
@@ -14576,7 +14576,7 @@
                 </a:solidFill>
                 <a:latin typeface="Open Sans"/>
               </a:rPr>
-              <a:t>GRILLA DE UMBRALES EVALUADA EN VALIDACIÓN</a:t>
+              <a:t>GRILLA DE UMBRALES DE MOMENTUM EVALUADA EN VALIDACIÓN</a:t>
             </a:r>
           </a:p>
         </p:txBody>
@@ -14590,20 +14590,18 @@
         <p:spPr>
           <a:xfrm>
             <a:off x="960120" y="6227064"/>
-            <a:ext cx="2377440" cy="914400"/>
+            <a:ext cx="11521440" cy="914400"/>
           </a:xfrm>
           <a:prstGeom prst="roundRect">
             <a:avLst>
-              <a:gd name="adj" fmla="val 5000"/>
+              <a:gd name="adj" fmla="val 6000"/>
             </a:avLst>
           </a:prstGeom>
           <a:solidFill>
             <a:srgbClr val="F5F7F9"/>
           </a:solidFill>
-          <a:ln w="9525">
-            <a:solidFill>
-              <a:srgbClr val="E2E6EA"/>
-            </a:solidFill>
+          <a:ln>
+            <a:noFill/>
           </a:ln>
           <a:effectLst/>
         </p:spPr>
@@ -14629,74 +14627,60 @@
           </a:p>
         </p:txBody>
       </p:sp>
-      <p:sp>
-        <p:nvSpPr>
-          <p:cNvPr id="21" name="TextBox 20"/>
-          <p:cNvSpPr txBox="1"/>
-          <p:nvPr/>
-        </p:nvSpPr>
-        <p:spPr>
-          <a:xfrm>
-            <a:off x="960120" y="6227064"/>
-            <a:ext cx="2377440" cy="914400"/>
-          </a:xfrm>
-          <a:prstGeom prst="rect">
-            <a:avLst/>
-          </a:prstGeom>
-          <a:noFill/>
-        </p:spPr>
-        <p:txBody>
-          <a:bodyPr wrap="square" lIns="0" rIns="0" tIns="0" bIns="0" anchor="ctr">
-            <a:spAutoFit/>
-          </a:bodyPr>
-          <a:lstStyle/>
-          <a:p>
-            <a:pPr algn="ctr">
-              <a:lnSpc>
-                <a:spcPct val="116000"/>
-              </a:lnSpc>
-              <a:spcBef>
-                <a:spcPts val="0"/>
-              </a:spcBef>
-              <a:spcAft>
-                <a:spcPts val="0"/>
-              </a:spcAft>
-            </a:pPr>
-            <a:r>
-              <a:rPr sz="1700" b="1" i="0">
-                <a:solidFill>
-                  <a:srgbClr val="6E6E6E"/>
-                </a:solidFill>
-                <a:latin typeface="Open Sans"/>
-              </a:rPr>
-              <a:t>1,05</a:t>
-            </a:r>
-          </a:p>
-        </p:txBody>
-      </p:sp>
-      <p:sp>
-        <p:nvSpPr>
-          <p:cNvPr id="22" name="Rounded Rectangle 21"/>
+      <p:cxnSp>
+        <p:nvCxnSpPr>
+          <p:cNvPr id="21" name="Connector 20"/>
+          <p:cNvCxnSpPr/>
+          <p:nvPr/>
+        </p:nvCxnSpPr>
+        <p:spPr>
+          <a:xfrm>
+            <a:off x="2331720" y="6684264"/>
+            <a:ext cx="8778239" cy="0"/>
+          </a:xfrm>
+          <a:prstGeom prst="line">
+            <a:avLst/>
+          </a:prstGeom>
+          <a:ln w="17780">
+            <a:solidFill>
+              <a:srgbClr val="9AA1A9"/>
+            </a:solidFill>
+          </a:ln>
+        </p:spPr>
+        <p:style>
+          <a:lnRef idx="2">
+            <a:schemeClr val="accent1"/>
+          </a:lnRef>
+          <a:fillRef idx="0">
+            <a:schemeClr val="accent1"/>
+          </a:fillRef>
+          <a:effectRef idx="1">
+            <a:schemeClr val="accent1"/>
+          </a:effectRef>
+          <a:fontRef idx="minor">
+            <a:schemeClr val="tx1"/>
+          </a:fontRef>
+        </p:style>
+      </p:cxnSp>
+      <p:sp>
+        <p:nvSpPr>
+          <p:cNvPr id="22" name="Rectangle 21"/>
           <p:cNvSpPr/>
           <p:nvPr/>
         </p:nvSpPr>
         <p:spPr>
           <a:xfrm>
-            <a:off x="3657600" y="6227064"/>
-            <a:ext cx="2377440" cy="914400"/>
-          </a:xfrm>
-          <a:prstGeom prst="roundRect">
-            <a:avLst>
-              <a:gd name="adj" fmla="val 5000"/>
-            </a:avLst>
+            <a:off x="2304288" y="6528816"/>
+            <a:ext cx="54864" cy="310896"/>
+          </a:xfrm>
+          <a:prstGeom prst="rect">
+            <a:avLst/>
           </a:prstGeom>
           <a:solidFill>
-            <a:srgbClr val="F5F7F9"/>
+            <a:srgbClr val="9AA1A9"/>
           </a:solidFill>
-          <a:ln w="9525">
-            <a:solidFill>
-              <a:srgbClr val="E2E6EA"/>
-            </a:solidFill>
+          <a:ln>
+            <a:noFill/>
           </a:ln>
           <a:effectLst/>
         </p:spPr>
@@ -14730,16 +14714,16 @@
         </p:nvSpPr>
         <p:spPr>
           <a:xfrm>
-            <a:off x="3657600" y="6227064"/>
-            <a:ext cx="2377440" cy="914400"/>
-          </a:xfrm>
-          <a:prstGeom prst="rect">
-            <a:avLst/>
-          </a:prstGeom>
-          <a:noFill/>
-        </p:spPr>
-        <p:txBody>
-          <a:bodyPr wrap="square" lIns="0" rIns="0" tIns="0" bIns="0" anchor="ctr">
+            <a:off x="1508760" y="6291072"/>
+            <a:ext cx="1645920" cy="274320"/>
+          </a:xfrm>
+          <a:prstGeom prst="rect">
+            <a:avLst/>
+          </a:prstGeom>
+          <a:noFill/>
+        </p:spPr>
+        <p:txBody>
+          <a:bodyPr wrap="square" lIns="0" rIns="0" tIns="0" bIns="0" anchor="t">
             <a:spAutoFit/>
           </a:bodyPr>
           <a:lstStyle/>
@@ -14756,32 +14740,119 @@
               </a:spcAft>
             </a:pPr>
             <a:r>
-              <a:rPr sz="1700" b="1" i="0">
-                <a:solidFill>
-                  <a:srgbClr val="6E6E6E"/>
-                </a:solidFill>
-                <a:latin typeface="Open Sans"/>
-              </a:rPr>
-              <a:t>1,15</a:t>
-            </a:r>
-          </a:p>
-        </p:txBody>
-      </p:sp>
-      <p:sp>
-        <p:nvSpPr>
-          <p:cNvPr id="24" name="Rounded Rectangle 23"/>
+              <a:rPr sz="1400" b="1" i="0">
+                <a:solidFill>
+                  <a:srgbClr val="13161B"/>
+                </a:solidFill>
+                <a:latin typeface="Open Sans"/>
+              </a:rPr>
+              <a:t>1,05</a:t>
+            </a:r>
+          </a:p>
+        </p:txBody>
+      </p:sp>
+      <p:sp>
+        <p:nvSpPr>
+          <p:cNvPr id="24" name="Rectangle 23"/>
           <p:cNvSpPr/>
           <p:nvPr/>
         </p:nvSpPr>
         <p:spPr>
           <a:xfrm>
-            <a:off x="6355080" y="6227064"/>
-            <a:ext cx="2377440" cy="914400"/>
-          </a:xfrm>
-          <a:prstGeom prst="roundRect">
-            <a:avLst>
-              <a:gd name="adj" fmla="val 5000"/>
-            </a:avLst>
+            <a:off x="11082528" y="6528816"/>
+            <a:ext cx="54864" cy="310896"/>
+          </a:xfrm>
+          <a:prstGeom prst="rect">
+            <a:avLst/>
+          </a:prstGeom>
+          <a:solidFill>
+            <a:srgbClr val="9AA1A9"/>
+          </a:solidFill>
+          <a:ln>
+            <a:noFill/>
+          </a:ln>
+          <a:effectLst/>
+        </p:spPr>
+        <p:style>
+          <a:lnRef idx="1">
+            <a:schemeClr val="accent1"/>
+          </a:lnRef>
+          <a:fillRef idx="3">
+            <a:schemeClr val="accent1"/>
+          </a:fillRef>
+          <a:effectRef idx="2">
+            <a:schemeClr val="accent1"/>
+          </a:effectRef>
+          <a:fontRef idx="minor">
+            <a:schemeClr val="lt1"/>
+          </a:fontRef>
+        </p:style>
+        <p:txBody>
+          <a:bodyPr rtlCol="0" anchor="ctr" wrap="none"/>
+          <a:lstStyle/>
+          <a:p>
+            <a:pPr algn="ctr"/>
+          </a:p>
+        </p:txBody>
+      </p:sp>
+      <p:sp>
+        <p:nvSpPr>
+          <p:cNvPr id="25" name="TextBox 24"/>
+          <p:cNvSpPr txBox="1"/>
+          <p:nvPr/>
+        </p:nvSpPr>
+        <p:spPr>
+          <a:xfrm>
+            <a:off x="10287000" y="6291072"/>
+            <a:ext cx="1645920" cy="274320"/>
+          </a:xfrm>
+          <a:prstGeom prst="rect">
+            <a:avLst/>
+          </a:prstGeom>
+          <a:noFill/>
+        </p:spPr>
+        <p:txBody>
+          <a:bodyPr wrap="square" lIns="0" rIns="0" tIns="0" bIns="0" anchor="t">
+            <a:spAutoFit/>
+          </a:bodyPr>
+          <a:lstStyle/>
+          <a:p>
+            <a:pPr algn="ctr">
+              <a:lnSpc>
+                <a:spcPct val="116000"/>
+              </a:lnSpc>
+              <a:spcBef>
+                <a:spcPts val="0"/>
+              </a:spcBef>
+              <a:spcAft>
+                <a:spcPts val="0"/>
+              </a:spcAft>
+            </a:pPr>
+            <a:r>
+              <a:rPr sz="1400" b="1" i="0">
+                <a:solidFill>
+                  <a:srgbClr val="13161B"/>
+                </a:solidFill>
+                <a:latin typeface="Open Sans"/>
+              </a:rPr>
+              <a:t>1,50</a:t>
+            </a:r>
+          </a:p>
+        </p:txBody>
+      </p:sp>
+      <p:sp>
+        <p:nvSpPr>
+          <p:cNvPr id="26" name="Rectangle 25"/>
+          <p:cNvSpPr/>
+          <p:nvPr/>
+        </p:nvSpPr>
+        <p:spPr>
+          <a:xfrm>
+            <a:off x="6665976" y="6455664"/>
+            <a:ext cx="91440" cy="457200"/>
+          </a:xfrm>
+          <a:prstGeom prst="rect">
+            <a:avLst/>
           </a:prstGeom>
           <a:solidFill>
             <a:srgbClr val="005F91"/>
@@ -14815,14 +14886,59 @@
       </p:sp>
       <p:sp>
         <p:nvSpPr>
-          <p:cNvPr id="25" name="TextBox 24"/>
-          <p:cNvSpPr txBox="1"/>
-          <p:nvPr/>
-        </p:nvSpPr>
-        <p:spPr>
-          <a:xfrm>
-            <a:off x="6355080" y="6227064"/>
-            <a:ext cx="2377440" cy="914400"/>
+          <p:cNvPr id="27" name="TextBox 26"/>
+          <p:cNvSpPr txBox="1"/>
+          <p:nvPr/>
+        </p:nvSpPr>
+        <p:spPr>
+          <a:xfrm>
+            <a:off x="5897880" y="6867144"/>
+            <a:ext cx="1645920" cy="274320"/>
+          </a:xfrm>
+          <a:prstGeom prst="rect">
+            <a:avLst/>
+          </a:prstGeom>
+          <a:noFill/>
+        </p:spPr>
+        <p:txBody>
+          <a:bodyPr wrap="square" lIns="0" rIns="0" tIns="0" bIns="0" anchor="t">
+            <a:spAutoFit/>
+          </a:bodyPr>
+          <a:lstStyle/>
+          <a:p>
+            <a:pPr algn="ctr">
+              <a:lnSpc>
+                <a:spcPct val="116000"/>
+              </a:lnSpc>
+              <a:spcBef>
+                <a:spcPts val="0"/>
+              </a:spcBef>
+              <a:spcAft>
+                <a:spcPts val="0"/>
+              </a:spcAft>
+            </a:pPr>
+            <a:r>
+              <a:rPr sz="1400" b="1" i="0">
+                <a:solidFill>
+                  <a:srgbClr val="005F91"/>
+                </a:solidFill>
+                <a:latin typeface="Open Sans"/>
+              </a:rPr>
+              <a:t>τ*</a:t>
+            </a:r>
+          </a:p>
+        </p:txBody>
+      </p:sp>
+      <p:sp>
+        <p:nvSpPr>
+          <p:cNvPr id="28" name="TextBox 27"/>
+          <p:cNvSpPr txBox="1"/>
+          <p:nvPr/>
+        </p:nvSpPr>
+        <p:spPr>
+          <a:xfrm>
+            <a:off x="12938760" y="6227064"/>
+            <a:ext cx="4389120" cy="914400"/>
           </a:xfrm>
           <a:prstGeom prst="rect">
             <a:avLst/>
@@ -14835,282 +14951,6 @@
           </a:bodyPr>
           <a:lstStyle/>
           <a:p>
-            <a:pPr algn="ctr">
-              <a:lnSpc>
-                <a:spcPct val="116000"/>
-              </a:lnSpc>
-              <a:spcBef>
-                <a:spcPts val="0"/>
-              </a:spcBef>
-              <a:spcAft>
-                <a:spcPts val="0"/>
-              </a:spcAft>
-            </a:pPr>
-            <a:r>
-              <a:rPr sz="1700" b="1" i="0">
-                <a:solidFill>
-                  <a:srgbClr val="FFFFFF"/>
-                </a:solidFill>
-                <a:latin typeface="Open Sans"/>
-              </a:rPr>
-              <a:t>1,25</a:t>
-            </a:r>
-          </a:p>
-        </p:txBody>
-      </p:sp>
-      <p:sp>
-        <p:nvSpPr>
-          <p:cNvPr id="26" name="Rounded Rectangle 25"/>
-          <p:cNvSpPr/>
-          <p:nvPr/>
-        </p:nvSpPr>
-        <p:spPr>
-          <a:xfrm>
-            <a:off x="9052560" y="6227064"/>
-            <a:ext cx="2377440" cy="914400"/>
-          </a:xfrm>
-          <a:prstGeom prst="roundRect">
-            <a:avLst>
-              <a:gd name="adj" fmla="val 5000"/>
-            </a:avLst>
-          </a:prstGeom>
-          <a:solidFill>
-            <a:srgbClr val="F5F7F9"/>
-          </a:solidFill>
-          <a:ln w="9525">
-            <a:solidFill>
-              <a:srgbClr val="E2E6EA"/>
-            </a:solidFill>
-          </a:ln>
-          <a:effectLst/>
-        </p:spPr>
-        <p:style>
-          <a:lnRef idx="1">
-            <a:schemeClr val="accent1"/>
-          </a:lnRef>
-          <a:fillRef idx="3">
-            <a:schemeClr val="accent1"/>
-          </a:fillRef>
-          <a:effectRef idx="2">
-            <a:schemeClr val="accent1"/>
-          </a:effectRef>
-          <a:fontRef idx="minor">
-            <a:schemeClr val="lt1"/>
-          </a:fontRef>
-        </p:style>
-        <p:txBody>
-          <a:bodyPr rtlCol="0" anchor="ctr" wrap="none"/>
-          <a:lstStyle/>
-          <a:p>
-            <a:pPr algn="ctr"/>
-          </a:p>
-        </p:txBody>
-      </p:sp>
-      <p:sp>
-        <p:nvSpPr>
-          <p:cNvPr id="27" name="TextBox 26"/>
-          <p:cNvSpPr txBox="1"/>
-          <p:nvPr/>
-        </p:nvSpPr>
-        <p:spPr>
-          <a:xfrm>
-            <a:off x="9052560" y="6227064"/>
-            <a:ext cx="2377440" cy="914400"/>
-          </a:xfrm>
-          <a:prstGeom prst="rect">
-            <a:avLst/>
-          </a:prstGeom>
-          <a:noFill/>
-        </p:spPr>
-        <p:txBody>
-          <a:bodyPr wrap="square" lIns="0" rIns="0" tIns="0" bIns="0" anchor="ctr">
-            <a:spAutoFit/>
-          </a:bodyPr>
-          <a:lstStyle/>
-          <a:p>
-            <a:pPr algn="ctr">
-              <a:lnSpc>
-                <a:spcPct val="116000"/>
-              </a:lnSpc>
-              <a:spcBef>
-                <a:spcPts val="0"/>
-              </a:spcBef>
-              <a:spcAft>
-                <a:spcPts val="0"/>
-              </a:spcAft>
-            </a:pPr>
-            <a:r>
-              <a:rPr sz="1700" b="1" i="0">
-                <a:solidFill>
-                  <a:srgbClr val="6E6E6E"/>
-                </a:solidFill>
-                <a:latin typeface="Open Sans"/>
-              </a:rPr>
-              <a:t>1,35</a:t>
-            </a:r>
-          </a:p>
-        </p:txBody>
-      </p:sp>
-      <p:sp>
-        <p:nvSpPr>
-          <p:cNvPr id="28" name="Rounded Rectangle 27"/>
-          <p:cNvSpPr/>
-          <p:nvPr/>
-        </p:nvSpPr>
-        <p:spPr>
-          <a:xfrm>
-            <a:off x="11750040" y="6227064"/>
-            <a:ext cx="2377440" cy="914400"/>
-          </a:xfrm>
-          <a:prstGeom prst="roundRect">
-            <a:avLst>
-              <a:gd name="adj" fmla="val 5000"/>
-            </a:avLst>
-          </a:prstGeom>
-          <a:solidFill>
-            <a:srgbClr val="F5F7F9"/>
-          </a:solidFill>
-          <a:ln w="9525">
-            <a:solidFill>
-              <a:srgbClr val="E2E6EA"/>
-            </a:solidFill>
-          </a:ln>
-          <a:effectLst/>
-        </p:spPr>
-        <p:style>
-          <a:lnRef idx="1">
-            <a:schemeClr val="accent1"/>
-          </a:lnRef>
-          <a:fillRef idx="3">
-            <a:schemeClr val="accent1"/>
-          </a:fillRef>
-          <a:effectRef idx="2">
-            <a:schemeClr val="accent1"/>
-          </a:effectRef>
-          <a:fontRef idx="minor">
-            <a:schemeClr val="lt1"/>
-          </a:fontRef>
-        </p:style>
-        <p:txBody>
-          <a:bodyPr rtlCol="0" anchor="ctr" wrap="none"/>
-          <a:lstStyle/>
-          <a:p>
-            <a:pPr algn="ctr"/>
-          </a:p>
-        </p:txBody>
-      </p:sp>
-      <p:sp>
-        <p:nvSpPr>
-          <p:cNvPr id="29" name="TextBox 28"/>
-          <p:cNvSpPr txBox="1"/>
-          <p:nvPr/>
-        </p:nvSpPr>
-        <p:spPr>
-          <a:xfrm>
-            <a:off x="11750040" y="6227064"/>
-            <a:ext cx="2377440" cy="914400"/>
-          </a:xfrm>
-          <a:prstGeom prst="rect">
-            <a:avLst/>
-          </a:prstGeom>
-          <a:noFill/>
-        </p:spPr>
-        <p:txBody>
-          <a:bodyPr wrap="square" lIns="0" rIns="0" tIns="0" bIns="0" anchor="ctr">
-            <a:spAutoFit/>
-          </a:bodyPr>
-          <a:lstStyle/>
-          <a:p>
-            <a:pPr algn="ctr">
-              <a:lnSpc>
-                <a:spcPct val="116000"/>
-              </a:lnSpc>
-              <a:spcBef>
-                <a:spcPts val="0"/>
-              </a:spcBef>
-              <a:spcAft>
-                <a:spcPts val="0"/>
-              </a:spcAft>
-            </a:pPr>
-            <a:r>
-              <a:rPr sz="1700" b="1" i="0">
-                <a:solidFill>
-                  <a:srgbClr val="6E6E6E"/>
-                </a:solidFill>
-                <a:latin typeface="Open Sans"/>
-              </a:rPr>
-              <a:t>1,50</a:t>
-            </a:r>
-          </a:p>
-        </p:txBody>
-      </p:sp>
-      <p:sp>
-        <p:nvSpPr>
-          <p:cNvPr id="30" name="TextBox 29"/>
-          <p:cNvSpPr txBox="1"/>
-          <p:nvPr/>
-        </p:nvSpPr>
-        <p:spPr>
-          <a:xfrm>
-            <a:off x="6355080" y="7232904"/>
-            <a:ext cx="2377440" cy="320040"/>
-          </a:xfrm>
-          <a:prstGeom prst="rect">
-            <a:avLst/>
-          </a:prstGeom>
-          <a:noFill/>
-        </p:spPr>
-        <p:txBody>
-          <a:bodyPr wrap="square" lIns="0" rIns="0" tIns="0" bIns="0" anchor="t">
-            <a:spAutoFit/>
-          </a:bodyPr>
-          <a:lstStyle/>
-          <a:p>
-            <a:pPr algn="ctr">
-              <a:lnSpc>
-                <a:spcPct val="116000"/>
-              </a:lnSpc>
-              <a:spcBef>
-                <a:spcPts val="0"/>
-              </a:spcBef>
-              <a:spcAft>
-                <a:spcPts val="0"/>
-              </a:spcAft>
-            </a:pPr>
-            <a:r>
-              <a:rPr sz="1200" b="1" i="0">
-                <a:solidFill>
-                  <a:srgbClr val="005F91"/>
-                </a:solidFill>
-                <a:latin typeface="Open Sans"/>
-              </a:rPr>
-              <a:t>τ* seleccionado</a:t>
-            </a:r>
-          </a:p>
-        </p:txBody>
-      </p:sp>
-      <p:sp>
-        <p:nvSpPr>
-          <p:cNvPr id="31" name="TextBox 30"/>
-          <p:cNvSpPr txBox="1"/>
-          <p:nvPr/>
-        </p:nvSpPr>
-        <p:spPr>
-          <a:xfrm>
-            <a:off x="14676120" y="6227064"/>
-            <a:ext cx="2651760" cy="914400"/>
-          </a:xfrm>
-          <a:prstGeom prst="rect">
-            <a:avLst/>
-          </a:prstGeom>
-          <a:noFill/>
-        </p:spPr>
-        <p:txBody>
-          <a:bodyPr wrap="square" lIns="0" rIns="0" tIns="0" bIns="0" anchor="ctr">
-            <a:spAutoFit/>
-          </a:bodyPr>
-          <a:lstStyle/>
-          <a:p>
             <a:pPr algn="l">
               <a:lnSpc>
                 <a:spcPct val="120000"/>
@@ -15123,20 +14963,20 @@
               </a:spcAft>
             </a:pPr>
             <a:r>
-              <a:rPr sz="1250" b="0" i="0">
-                <a:solidFill>
-                  <a:srgbClr val="9AA1A9"/>
-                </a:solidFill>
-                <a:latin typeface="Open Sans"/>
-              </a:rPr>
-              <a:t>...para cada umbral se reoptimizan los pesos</a:t>
-            </a:r>
-          </a:p>
-        </p:txBody>
-      </p:sp>
-      <p:sp>
-        <p:nvSpPr>
-          <p:cNvPr id="32" name="Rounded Rectangle 31"/>
+              <a:rPr sz="1280" b="0" i="0">
+                <a:solidFill>
+                  <a:srgbClr val="394049"/>
+                </a:solidFill>
+                <a:latin typeface="Open Sans"/>
+              </a:rPr>
+              <a:t>Para cada umbral de la grilla se reoptimizan los pesos de ruteo; se adopta el que minimiza el WAPE en validación.</a:t>
+            </a:r>
+          </a:p>
+        </p:txBody>
+      </p:sp>
+      <p:sp>
+        <p:nvSpPr>
+          <p:cNvPr id="29" name="Rounded Rectangle 28"/>
           <p:cNvSpPr/>
           <p:nvPr/>
         </p:nvSpPr>
@@ -15182,7 +15022,7 @@
       </p:sp>
       <p:sp>
         <p:nvSpPr>
-          <p:cNvPr id="33" name="TextBox 32"/>
+          <p:cNvPr id="30" name="TextBox 29"/>
           <p:cNvSpPr txBox="1"/>
           <p:nvPr/>
         </p:nvSpPr>

</xml_diff>